<commit_message>
docs(demo): fit scene 1 and 2 rows on the slide
Co-Authored-By: Claude Sonnet 5.5 <noreply@anthropic.com>
</commit_message>
<xml_diff>
--- a/docs/demo/annona-demo.pptx
+++ b/docs/demo/annona-demo.pptx
@@ -116,30 +116,30 @@
   <p:extLst>
     <p:ext uri="{521415D9-36F7-43E2-AB2F-B90AF26B5E84}">
       <p14:sectionLst xmlns:p14="http://schemas.microsoft.com/office/powerpoint/2010/main">
-        <p14:section name="Open" id="{7595fe85-4aa4-86b6-db16-da079a707843}">
+        <p14:section name="Open" id="{ca4be1c7-52bb-df26-26e3-12f58b4cab98}">
           <p14:sldIdLst>
             <p14:sldId id="256"/>
           </p14:sldIdLst>
         </p14:section>
-        <p14:section name="Why" id="{50440ac2-45d8-d935-94a3-2e92e34f94fc}">
+        <p14:section name="Why" id="{25b07e98-9a4d-a916-9ab6-34323fabea8c}">
           <p14:sldIdLst>
             <p14:sldId id="257"/>
           </p14:sldIdLst>
         </p14:section>
-        <p14:section name="Product" id="{cb55f454-6f50-5736-8b95-60c771376761}">
+        <p14:section name="Product" id="{62f31ac0-1db9-7840-868f-ab063708fe85}">
           <p14:sldIdLst>
             <p14:sldId id="258"/>
             <p14:sldId id="259"/>
           </p14:sldIdLst>
         </p14:section>
-        <p14:section name="Live demo" id="{67e9c33d-fa67-f0e5-ea25-141e8c0d1198}">
+        <p14:section name="Live demo" id="{46ddf84a-f71b-81af-e14f-bcfed1aa1fac}">
           <p14:sldIdLst>
             <p14:sldId id="260"/>
             <p14:sldId id="261"/>
             <p14:sldId id="262"/>
           </p14:sldIdLst>
         </p14:section>
-        <p14:section name="Honesty" id="{96a922af-6282-b984-8d65-6691ffcc983d}">
+        <p14:section name="Honesty" id="{cc02bf23-0260-b580-b7b7-9f7ddd3a562e}">
           <p14:sldIdLst>
             <p14:sldId id="263"/>
             <p14:sldId id="264"/>
@@ -4201,12 +4201,12 @@
         </p:nvSpPr>
         <p:spPr>
           <a:xfrm>
-            <a:off x="548640" y="1371600"/>
-            <a:ext cx="8046720" cy="603504"/>
+            <a:off x="548640" y="1280160"/>
+            <a:ext cx="8046720" cy="493776"/>
           </a:xfrm>
           <a:prstGeom prst="roundRect">
             <a:avLst>
-              <a:gd name="adj" fmla="val 18182"/>
+              <a:gd name="adj" fmla="val 22222"/>
             </a:avLst>
           </a:prstGeom>
           <a:solidFill>
@@ -4235,7 +4235,7 @@
         </p:nvSpPr>
         <p:spPr>
           <a:xfrm>
-            <a:off x="685800" y="1490472"/>
+            <a:off x="685800" y="1344168"/>
             <a:ext cx="365760" cy="365760"/>
           </a:xfrm>
           <a:prstGeom prst="ellipse">
@@ -4260,7 +4260,7 @@
         </p:nvSpPr>
         <p:spPr>
           <a:xfrm>
-            <a:off x="685800" y="1490472"/>
+            <a:off x="685800" y="1344168"/>
             <a:ext cx="365760" cy="365760"/>
           </a:xfrm>
           <a:prstGeom prst="rect">
@@ -4296,8 +4296,8 @@
         </p:nvSpPr>
         <p:spPr>
           <a:xfrm>
-            <a:off x="1234440" y="1444752"/>
-            <a:ext cx="1737360" cy="457200"/>
+            <a:off x="1234440" y="1280160"/>
+            <a:ext cx="1554480" cy="493776"/>
           </a:xfrm>
           <a:prstGeom prst="rect">
             <a:avLst/>
@@ -4332,8 +4332,8 @@
         </p:nvSpPr>
         <p:spPr>
           <a:xfrm>
-            <a:off x="3017520" y="1444752"/>
-            <a:ext cx="5440680" cy="457200"/>
+            <a:off x="2834640" y="1280160"/>
+            <a:ext cx="5623560" cy="493776"/>
           </a:xfrm>
           <a:prstGeom prst="rect">
             <a:avLst/>
@@ -4354,7 +4354,7 @@
                   <a:schemeClr val="tx1"/>
                 </a:solidFill>
               </a:rPr>
-              <a:t>Texts a photo of a refrigerated sandwich and wrap platter</a:t>
+              <a:t>Texts a photo of a refrigerated sandwich platter</a:t>
             </a:r>
             <a:endParaRPr lang="en-US" sz="1400" dirty="0"/>
           </a:p>
@@ -4368,12 +4368,12 @@
         </p:nvSpPr>
         <p:spPr>
           <a:xfrm>
-            <a:off x="548640" y="2084832"/>
-            <a:ext cx="8046720" cy="603504"/>
+            <a:off x="548640" y="1865376"/>
+            <a:ext cx="8046720" cy="493776"/>
           </a:xfrm>
           <a:prstGeom prst="roundRect">
             <a:avLst>
-              <a:gd name="adj" fmla="val 18182"/>
+              <a:gd name="adj" fmla="val 22222"/>
             </a:avLst>
           </a:prstGeom>
           <a:solidFill>
@@ -4402,7 +4402,7 @@
         </p:nvSpPr>
         <p:spPr>
           <a:xfrm>
-            <a:off x="685800" y="2203704"/>
+            <a:off x="685800" y="1929384"/>
             <a:ext cx="365760" cy="365760"/>
           </a:xfrm>
           <a:prstGeom prst="ellipse">
@@ -4427,7 +4427,7 @@
         </p:nvSpPr>
         <p:spPr>
           <a:xfrm>
-            <a:off x="685800" y="2203704"/>
+            <a:off x="685800" y="1929384"/>
             <a:ext cx="365760" cy="365760"/>
           </a:xfrm>
           <a:prstGeom prst="rect">
@@ -4463,8 +4463,8 @@
         </p:nvSpPr>
         <p:spPr>
           <a:xfrm>
-            <a:off x="1234440" y="2157984"/>
-            <a:ext cx="1737360" cy="457200"/>
+            <a:off x="1234440" y="1865376"/>
+            <a:ext cx="1554480" cy="493776"/>
           </a:xfrm>
           <a:prstGeom prst="rect">
             <a:avLst/>
@@ -4499,8 +4499,8 @@
         </p:nvSpPr>
         <p:spPr>
           <a:xfrm>
-            <a:off x="3017520" y="2157984"/>
-            <a:ext cx="5440680" cy="457200"/>
+            <a:off x="2834640" y="1865376"/>
+            <a:ext cx="5623560" cy="493776"/>
           </a:xfrm>
           <a:prstGeom prst="rect">
             <a:avLst/>
@@ -4535,12 +4535,12 @@
         </p:nvSpPr>
         <p:spPr>
           <a:xfrm>
-            <a:off x="548640" y="2798064"/>
-            <a:ext cx="8046720" cy="603504"/>
+            <a:off x="548640" y="2450592"/>
+            <a:ext cx="8046720" cy="493776"/>
           </a:xfrm>
           <a:prstGeom prst="roundRect">
             <a:avLst>
-              <a:gd name="adj" fmla="val 18182"/>
+              <a:gd name="adj" fmla="val 22222"/>
             </a:avLst>
           </a:prstGeom>
           <a:solidFill>
@@ -4569,7 +4569,7 @@
         </p:nvSpPr>
         <p:spPr>
           <a:xfrm>
-            <a:off x="685800" y="2916936"/>
+            <a:off x="685800" y="2514600"/>
             <a:ext cx="365760" cy="365760"/>
           </a:xfrm>
           <a:prstGeom prst="ellipse">
@@ -4594,7 +4594,7 @@
         </p:nvSpPr>
         <p:spPr>
           <a:xfrm>
-            <a:off x="685800" y="2916936"/>
+            <a:off x="685800" y="2514600"/>
             <a:ext cx="365760" cy="365760"/>
           </a:xfrm>
           <a:prstGeom prst="rect">
@@ -4630,8 +4630,8 @@
         </p:nvSpPr>
         <p:spPr>
           <a:xfrm>
-            <a:off x="1234440" y="2871216"/>
-            <a:ext cx="1737360" cy="457200"/>
+            <a:off x="1234440" y="2450592"/>
+            <a:ext cx="1554480" cy="493776"/>
           </a:xfrm>
           <a:prstGeom prst="rect">
             <a:avLst/>
@@ -4666,8 +4666,8 @@
         </p:nvSpPr>
         <p:spPr>
           <a:xfrm>
-            <a:off x="3017520" y="2871216"/>
-            <a:ext cx="5440680" cy="457200"/>
+            <a:off x="2834640" y="2450592"/>
+            <a:ext cx="5623560" cy="493776"/>
           </a:xfrm>
           <a:prstGeom prst="rect">
             <a:avLst/>
@@ -4688,7 +4688,7 @@
                   <a:schemeClr val="tx1"/>
                 </a:solidFill>
               </a:rPr>
-              <a:t>Corrects servings to 24, declares all nine allergens, attests handling</a:t>
+              <a:t>Sets servings to 24, declares allergens and handling</a:t>
             </a:r>
             <a:endParaRPr lang="en-US" sz="1400" dirty="0"/>
           </a:p>
@@ -4702,12 +4702,12 @@
         </p:nvSpPr>
         <p:spPr>
           <a:xfrm>
-            <a:off x="548640" y="3511296"/>
-            <a:ext cx="8046720" cy="603504"/>
+            <a:off x="548640" y="3035808"/>
+            <a:ext cx="8046720" cy="493776"/>
           </a:xfrm>
           <a:prstGeom prst="roundRect">
             <a:avLst>
-              <a:gd name="adj" fmla="val 18182"/>
+              <a:gd name="adj" fmla="val 22222"/>
             </a:avLst>
           </a:prstGeom>
           <a:solidFill>
@@ -4736,7 +4736,7 @@
         </p:nvSpPr>
         <p:spPr>
           <a:xfrm>
-            <a:off x="685800" y="3630168"/>
+            <a:off x="685800" y="3099816"/>
             <a:ext cx="365760" cy="365760"/>
           </a:xfrm>
           <a:prstGeom prst="ellipse">
@@ -4761,7 +4761,7 @@
         </p:nvSpPr>
         <p:spPr>
           <a:xfrm>
-            <a:off x="685800" y="3630168"/>
+            <a:off x="685800" y="3099816"/>
             <a:ext cx="365760" cy="365760"/>
           </a:xfrm>
           <a:prstGeom prst="rect">
@@ -4797,8 +4797,8 @@
         </p:nvSpPr>
         <p:spPr>
           <a:xfrm>
-            <a:off x="1234440" y="3584448"/>
-            <a:ext cx="1737360" cy="457200"/>
+            <a:off x="1234440" y="3035808"/>
+            <a:ext cx="1554480" cy="493776"/>
           </a:xfrm>
           <a:prstGeom prst="rect">
             <a:avLst/>
@@ -4833,8 +4833,8 @@
         </p:nvSpPr>
         <p:spPr>
           <a:xfrm>
-            <a:off x="3017520" y="3584448"/>
-            <a:ext cx="5440680" cy="457200"/>
+            <a:off x="2834640" y="3035808"/>
+            <a:ext cx="5623560" cy="493776"/>
           </a:xfrm>
           <a:prstGeom prst="rect">
             <a:avLst/>
@@ -4869,12 +4869,12 @@
         </p:nvSpPr>
         <p:spPr>
           <a:xfrm>
-            <a:off x="548640" y="4224528"/>
-            <a:ext cx="8046720" cy="603504"/>
+            <a:off x="548640" y="3621024"/>
+            <a:ext cx="8046720" cy="493776"/>
           </a:xfrm>
           <a:prstGeom prst="roundRect">
             <a:avLst>
-              <a:gd name="adj" fmla="val 18182"/>
+              <a:gd name="adj" fmla="val 22222"/>
             </a:avLst>
           </a:prstGeom>
           <a:solidFill>
@@ -4903,7 +4903,7 @@
         </p:nvSpPr>
         <p:spPr>
           <a:xfrm>
-            <a:off x="685800" y="4343400"/>
+            <a:off x="685800" y="3685032"/>
             <a:ext cx="365760" cy="365760"/>
           </a:xfrm>
           <a:prstGeom prst="ellipse">
@@ -4928,7 +4928,7 @@
         </p:nvSpPr>
         <p:spPr>
           <a:xfrm>
-            <a:off x="685800" y="4343400"/>
+            <a:off x="685800" y="3685032"/>
             <a:ext cx="365760" cy="365760"/>
           </a:xfrm>
           <a:prstGeom prst="rect">
@@ -4964,8 +4964,8 @@
         </p:nvSpPr>
         <p:spPr>
           <a:xfrm>
-            <a:off x="1234440" y="4297680"/>
-            <a:ext cx="1737360" cy="457200"/>
+            <a:off x="1234440" y="3621024"/>
+            <a:ext cx="1554480" cy="493776"/>
           </a:xfrm>
           <a:prstGeom prst="rect">
             <a:avLst/>
@@ -5000,8 +5000,8 @@
         </p:nvSpPr>
         <p:spPr>
           <a:xfrm>
-            <a:off x="3017520" y="4297680"/>
-            <a:ext cx="5440680" cy="457200"/>
+            <a:off x="2834640" y="3621024"/>
+            <a:ext cx="5623560" cy="493776"/>
           </a:xfrm>
           <a:prstGeom prst="rect">
             <a:avLst/>
@@ -5022,7 +5022,7 @@
                   <a:schemeClr val="tx1"/>
                 </a:solidFill>
               </a:rPr>
-              <a:t>Gets a time-limited offer, replies YES with the code</a:t>
+              <a:t>Gets a timed offer, replies YES with the code</a:t>
             </a:r>
             <a:endParaRPr lang="en-US" sz="1400" dirty="0"/>
           </a:p>
@@ -5036,12 +5036,12 @@
         </p:nvSpPr>
         <p:spPr>
           <a:xfrm>
-            <a:off x="548640" y="4937760"/>
-            <a:ext cx="8046720" cy="603504"/>
+            <a:off x="548640" y="4206240"/>
+            <a:ext cx="8046720" cy="493776"/>
           </a:xfrm>
           <a:prstGeom prst="roundRect">
             <a:avLst>
-              <a:gd name="adj" fmla="val 18182"/>
+              <a:gd name="adj" fmla="val 22222"/>
             </a:avLst>
           </a:prstGeom>
           <a:solidFill>
@@ -5070,7 +5070,7 @@
         </p:nvSpPr>
         <p:spPr>
           <a:xfrm>
-            <a:off x="685800" y="5056632"/>
+            <a:off x="685800" y="4270248"/>
             <a:ext cx="365760" cy="365760"/>
           </a:xfrm>
           <a:prstGeom prst="ellipse">
@@ -5095,7 +5095,7 @@
         </p:nvSpPr>
         <p:spPr>
           <a:xfrm>
-            <a:off x="685800" y="5056632"/>
+            <a:off x="685800" y="4270248"/>
             <a:ext cx="365760" cy="365760"/>
           </a:xfrm>
           <a:prstGeom prst="rect">
@@ -5131,8 +5131,8 @@
         </p:nvSpPr>
         <p:spPr>
           <a:xfrm>
-            <a:off x="1234440" y="5010912"/>
-            <a:ext cx="1737360" cy="457200"/>
+            <a:off x="1234440" y="4206240"/>
+            <a:ext cx="1554480" cy="493776"/>
           </a:xfrm>
           <a:prstGeom prst="rect">
             <a:avLst/>
@@ -5167,8 +5167,8 @@
         </p:nvSpPr>
         <p:spPr>
           <a:xfrm>
-            <a:off x="3017520" y="5010912"/>
-            <a:ext cx="5440680" cy="457200"/>
+            <a:off x="2834640" y="4206240"/>
+            <a:ext cx="5623560" cy="493776"/>
           </a:xfrm>
           <a:prstGeom prst="rect">
             <a:avLst/>
@@ -5189,7 +5189,7 @@
                   <a:schemeClr val="tx1"/>
                 </a:solidFill>
               </a:rPr>
-              <a:t>Claimed. Operator marks simulated pickup and delivery</a:t>
+              <a:t>Claimed; pickup and delivery are simulated</a:t>
             </a:r>
             <a:endParaRPr lang="en-US" sz="1400" dirty="0"/>
           </a:p>
@@ -5311,12 +5311,12 @@
         </p:nvSpPr>
         <p:spPr>
           <a:xfrm>
-            <a:off x="548640" y="1371600"/>
-            <a:ext cx="8046720" cy="603504"/>
+            <a:off x="548640" y="1280160"/>
+            <a:ext cx="8046720" cy="621792"/>
           </a:xfrm>
           <a:prstGeom prst="roundRect">
             <a:avLst>
-              <a:gd name="adj" fmla="val 18182"/>
+              <a:gd name="adj" fmla="val 17647"/>
             </a:avLst>
           </a:prstGeom>
           <a:solidFill>
@@ -5345,7 +5345,7 @@
         </p:nvSpPr>
         <p:spPr>
           <a:xfrm>
-            <a:off x="685800" y="1490472"/>
+            <a:off x="685800" y="1408176"/>
             <a:ext cx="365760" cy="365760"/>
           </a:xfrm>
           <a:prstGeom prst="ellipse">
@@ -5370,7 +5370,7 @@
         </p:nvSpPr>
         <p:spPr>
           <a:xfrm>
-            <a:off x="685800" y="1490472"/>
+            <a:off x="685800" y="1408176"/>
             <a:ext cx="365760" cy="365760"/>
           </a:xfrm>
           <a:prstGeom prst="rect">
@@ -5406,8 +5406,8 @@
         </p:nvSpPr>
         <p:spPr>
           <a:xfrm>
-            <a:off x="1234440" y="1444752"/>
-            <a:ext cx="1737360" cy="457200"/>
+            <a:off x="1234440" y="1280160"/>
+            <a:ext cx="1554480" cy="621792"/>
           </a:xfrm>
           <a:prstGeom prst="rect">
             <a:avLst/>
@@ -5442,8 +5442,8 @@
         </p:nvSpPr>
         <p:spPr>
           <a:xfrm>
-            <a:off x="3017520" y="1444752"/>
-            <a:ext cx="5440680" cy="457200"/>
+            <a:off x="2834640" y="1280160"/>
+            <a:ext cx="5623560" cy="621792"/>
           </a:xfrm>
           <a:prstGeom prst="rect">
             <a:avLst/>
@@ -5478,12 +5478,12 @@
         </p:nvSpPr>
         <p:spPr>
           <a:xfrm>
-            <a:off x="548640" y="2084832"/>
-            <a:ext cx="8046720" cy="603504"/>
+            <a:off x="548640" y="1993392"/>
+            <a:ext cx="8046720" cy="621792"/>
           </a:xfrm>
           <a:prstGeom prst="roundRect">
             <a:avLst>
-              <a:gd name="adj" fmla="val 18182"/>
+              <a:gd name="adj" fmla="val 17647"/>
             </a:avLst>
           </a:prstGeom>
           <a:solidFill>
@@ -5512,7 +5512,7 @@
         </p:nvSpPr>
         <p:spPr>
           <a:xfrm>
-            <a:off x="685800" y="2203704"/>
+            <a:off x="685800" y="2121408"/>
             <a:ext cx="365760" cy="365760"/>
           </a:xfrm>
           <a:prstGeom prst="ellipse">
@@ -5537,7 +5537,7 @@
         </p:nvSpPr>
         <p:spPr>
           <a:xfrm>
-            <a:off x="685800" y="2203704"/>
+            <a:off x="685800" y="2121408"/>
             <a:ext cx="365760" cy="365760"/>
           </a:xfrm>
           <a:prstGeom prst="rect">
@@ -5573,8 +5573,8 @@
         </p:nvSpPr>
         <p:spPr>
           <a:xfrm>
-            <a:off x="1234440" y="2157984"/>
-            <a:ext cx="1737360" cy="457200"/>
+            <a:off x="1234440" y="1993392"/>
+            <a:ext cx="1554480" cy="621792"/>
           </a:xfrm>
           <a:prstGeom prst="rect">
             <a:avLst/>
@@ -5609,8 +5609,8 @@
         </p:nvSpPr>
         <p:spPr>
           <a:xfrm>
-            <a:off x="3017520" y="2157984"/>
-            <a:ext cx="5440680" cy="457200"/>
+            <a:off x="2834640" y="1993392"/>
+            <a:ext cx="5623560" cy="621792"/>
           </a:xfrm>
           <a:prstGeom prst="rect">
             <a:avLst/>
@@ -5645,12 +5645,12 @@
         </p:nvSpPr>
         <p:spPr>
           <a:xfrm>
-            <a:off x="548640" y="2798064"/>
-            <a:ext cx="8046720" cy="603504"/>
+            <a:off x="548640" y="2706624"/>
+            <a:ext cx="8046720" cy="621792"/>
           </a:xfrm>
           <a:prstGeom prst="roundRect">
             <a:avLst>
-              <a:gd name="adj" fmla="val 18182"/>
+              <a:gd name="adj" fmla="val 17647"/>
             </a:avLst>
           </a:prstGeom>
           <a:solidFill>
@@ -5679,7 +5679,7 @@
         </p:nvSpPr>
         <p:spPr>
           <a:xfrm>
-            <a:off x="685800" y="2916936"/>
+            <a:off x="685800" y="2834640"/>
             <a:ext cx="365760" cy="365760"/>
           </a:xfrm>
           <a:prstGeom prst="ellipse">
@@ -5704,7 +5704,7 @@
         </p:nvSpPr>
         <p:spPr>
           <a:xfrm>
-            <a:off x="685800" y="2916936"/>
+            <a:off x="685800" y="2834640"/>
             <a:ext cx="365760" cy="365760"/>
           </a:xfrm>
           <a:prstGeom prst="rect">
@@ -5740,8 +5740,8 @@
         </p:nvSpPr>
         <p:spPr>
           <a:xfrm>
-            <a:off x="1234440" y="2871216"/>
-            <a:ext cx="1737360" cy="457200"/>
+            <a:off x="1234440" y="2706624"/>
+            <a:ext cx="1554480" cy="621792"/>
           </a:xfrm>
           <a:prstGeom prst="rect">
             <a:avLst/>
@@ -5776,8 +5776,8 @@
         </p:nvSpPr>
         <p:spPr>
           <a:xfrm>
-            <a:off x="3017520" y="2871216"/>
-            <a:ext cx="5440680" cy="457200"/>
+            <a:off x="2834640" y="2706624"/>
+            <a:ext cx="5623560" cy="621792"/>
           </a:xfrm>
           <a:prstGeom prst="rect">
             <a:avLst/>
@@ -5812,12 +5812,12 @@
         </p:nvSpPr>
         <p:spPr>
           <a:xfrm>
-            <a:off x="548640" y="3511296"/>
-            <a:ext cx="8046720" cy="603504"/>
+            <a:off x="548640" y="3419856"/>
+            <a:ext cx="8046720" cy="621792"/>
           </a:xfrm>
           <a:prstGeom prst="roundRect">
             <a:avLst>
-              <a:gd name="adj" fmla="val 18182"/>
+              <a:gd name="adj" fmla="val 17647"/>
             </a:avLst>
           </a:prstGeom>
           <a:solidFill>
@@ -5846,7 +5846,7 @@
         </p:nvSpPr>
         <p:spPr>
           <a:xfrm>
-            <a:off x="685800" y="3630168"/>
+            <a:off x="685800" y="3547872"/>
             <a:ext cx="365760" cy="365760"/>
           </a:xfrm>
           <a:prstGeom prst="ellipse">
@@ -5871,7 +5871,7 @@
         </p:nvSpPr>
         <p:spPr>
           <a:xfrm>
-            <a:off x="685800" y="3630168"/>
+            <a:off x="685800" y="3547872"/>
             <a:ext cx="365760" cy="365760"/>
           </a:xfrm>
           <a:prstGeom prst="rect">
@@ -5907,8 +5907,8 @@
         </p:nvSpPr>
         <p:spPr>
           <a:xfrm>
-            <a:off x="1234440" y="3584448"/>
-            <a:ext cx="1737360" cy="457200"/>
+            <a:off x="1234440" y="3419856"/>
+            <a:ext cx="1554480" cy="621792"/>
           </a:xfrm>
           <a:prstGeom prst="rect">
             <a:avLst/>
@@ -5943,8 +5943,8 @@
         </p:nvSpPr>
         <p:spPr>
           <a:xfrm>
-            <a:off x="3017520" y="3584448"/>
-            <a:ext cx="5440680" cy="457200"/>
+            <a:off x="2834640" y="3419856"/>
+            <a:ext cx="5623560" cy="621792"/>
           </a:xfrm>
           <a:prstGeom prst="rect">
             <a:avLst/>

</xml_diff>